<commit_message>
docs: atualizar apresentacao STAR (pptx e pdf) com versao revisada
</commit_message>
<xml_diff>
--- a/docs/Apresentacao_Tech_Challenge_1_MLE10_Churn.pptx
+++ b/docs/Apresentacao_Tech_Challenge_1_MLE10_Churn.pptx
@@ -123,6 +123,7 @@
 <p1510:revInfo xmlns:a="http://schemas.openxmlformats.org/drawingml/2006/main" xmlns:r="http://schemas.openxmlformats.org/officeDocument/2006/relationships" xmlns:p1510="http://schemas.microsoft.com/office/powerpoint/2015/10/main">
   <p1510:revLst>
     <p1510:client id="{4C85A211-7014-2639-B4B4-9C710FCE1654}" v="19" dt="2026-06-28T14:29:49.311"/>
+    <p1510:client id="{88413715-0CD2-270D-08AA-4B2FD4070624}" v="32" dt="2026-06-28T22:12:20.985"/>
     <p1510:client id="{9C2D4FBA-F40E-43BD-7486-E1CCDFA66667}" v="398" dt="2026-06-28T17:33:08.795"/>
   </p1510:revLst>
 </p1510:revInfo>
@@ -5920,7 +5921,7 @@
           <p:nvPr>
             <p:extLst>
               <p:ext uri="{D42A27DB-BD31-4B8C-83A1-F6EECF244321}">
-                <p14:modId xmlns:p14="http://schemas.microsoft.com/office/powerpoint/2010/main" val="1579011935"/>
+                <p14:modId xmlns:p14="http://schemas.microsoft.com/office/powerpoint/2010/main" val="2972944204"/>
               </p:ext>
             </p:extLst>
           </p:nvPr>
@@ -6248,24 +6249,49 @@
                     <a:bodyPr/>
                     <a:lstStyle/>
                     <a:p>
-                      <a:pPr marL="0" indent="0">
+                      <a:pPr lvl="0" algn="l">
+                        <a:lnSpc>
+                          <a:spcPct val="100000"/>
+                        </a:lnSpc>
+                        <a:spcBef>
+                          <a:spcPts val="0"/>
+                        </a:spcBef>
+                        <a:spcAft>
+                          <a:spcPts val="0"/>
+                        </a:spcAft>
                         <a:buNone/>
                       </a:pPr>
                       <a:r>
-                        <a:rPr lang="en-US" sz="1300" dirty="0">
+                        <a:rPr lang="en-US" sz="1300" kern="1200" noProof="0">
                           <a:solidFill>
                             <a:srgbClr val="5E7C94"/>
                           </a:solidFill>
-                          <a:latin typeface="Calibri" pitchFamily="34" charset="0"/>
-                          <a:ea typeface="Calibri" pitchFamily="34" charset="-122"/>
-                          <a:cs typeface="Calibri" pitchFamily="34" charset="-120"/>
+                          <a:latin typeface="Calibri"/>
+                          <a:ea typeface="Calibri"/>
+                          <a:cs typeface="Calibri"/>
                         </a:rPr>
-                        <a:t>Sem modelo (aleatório)</a:t>
+                        <a:t>Dummy Classifier</a:t>
                       </a:r>
-                      <a:endParaRPr lang="en-US" sz="1300" dirty="0">
-                        <a:latin typeface="Calibri" charset="0"/>
-                        <a:ea typeface="Calibri" charset="0"/>
-                        <a:cs typeface="Calibri" charset="0"/>
+                      <a:endParaRPr lang="pt-BR" sz="1300" kern="1200">
+                        <a:solidFill>
+                          <a:srgbClr val="5E7C94"/>
+                        </a:solidFill>
+                        <a:latin typeface="Calibri"/>
+                        <a:ea typeface="Calibri"/>
+                        <a:cs typeface="Calibri"/>
+                      </a:endParaRPr>
+                    </a:p>
+                    <a:p>
+                      <a:pPr marL="0" lvl="0" indent="0">
+                        <a:buNone/>
+                      </a:pPr>
+                      <a:endParaRPr lang="en-US" sz="1300" kern="1200" dirty="0">
+                        <a:solidFill>
+                          <a:srgbClr val="5E7C94"/>
+                        </a:solidFill>
+                        <a:latin typeface="Calibri"/>
+                        <a:ea typeface="Calibri"/>
+                        <a:cs typeface="Calibri"/>
                       </a:endParaRPr>
                     </a:p>
                   </a:txBody>
@@ -6317,21 +6343,16 @@
                         <a:buNone/>
                       </a:pPr>
                       <a:r>
-                        <a:rPr lang="en-US" sz="1300" dirty="0">
+                        <a:rPr lang="en-US" sz="1300" kern="1200" dirty="0">
                           <a:solidFill>
                             <a:srgbClr val="5E7C94"/>
                           </a:solidFill>
-                          <a:latin typeface="Calibri" pitchFamily="34" charset="0"/>
-                          <a:ea typeface="Calibri" pitchFamily="34" charset="-122"/>
-                          <a:cs typeface="Calibri" pitchFamily="34" charset="-120"/>
+                          <a:latin typeface="Calibri"/>
+                          <a:ea typeface="Calibri"/>
+                          <a:cs typeface="Calibri"/>
                         </a:rPr>
                         <a:t>0,52</a:t>
                       </a:r>
-                      <a:endParaRPr lang="en-US" sz="1300" dirty="0">
-                        <a:latin typeface="Calibri" charset="0"/>
-                        <a:ea typeface="Calibri" charset="0"/>
-                        <a:cs typeface="Calibri" charset="0"/>
-                      </a:endParaRPr>
                     </a:p>
                   </a:txBody>
                   <a:tcPr>
@@ -6382,21 +6403,16 @@
                         <a:buNone/>
                       </a:pPr>
                       <a:r>
-                        <a:rPr lang="en-US" sz="1300" dirty="0">
+                        <a:rPr lang="en-US" sz="1300" kern="1200" dirty="0">
                           <a:solidFill>
                             <a:srgbClr val="5E7C94"/>
                           </a:solidFill>
-                          <a:latin typeface="Calibri" pitchFamily="34" charset="0"/>
-                          <a:ea typeface="Calibri" pitchFamily="34" charset="-122"/>
-                          <a:cs typeface="Calibri" pitchFamily="34" charset="-120"/>
+                          <a:latin typeface="Calibri"/>
+                          <a:ea typeface="Calibri"/>
+                          <a:cs typeface="Calibri"/>
                         </a:rPr>
                         <a:t>0,29</a:t>
                       </a:r>
-                      <a:endParaRPr lang="en-US" sz="1300" dirty="0">
-                        <a:latin typeface="Calibri" charset="0"/>
-                        <a:ea typeface="Calibri" charset="0"/>
-                        <a:cs typeface="Calibri" charset="0"/>
-                      </a:endParaRPr>
                     </a:p>
                   </a:txBody>
                   <a:tcPr>
@@ -6447,20 +6463,45 @@
                         <a:buNone/>
                       </a:pPr>
                       <a:r>
-                        <a:rPr lang="en-US" sz="1300" dirty="0">
+                        <a:rPr lang="en-US" sz="1300" kern="1200" dirty="0" err="1">
                           <a:solidFill>
                             <a:srgbClr val="5E7C94"/>
                           </a:solidFill>
-                          <a:latin typeface="Calibri" pitchFamily="34" charset="0"/>
-                          <a:ea typeface="Calibri" pitchFamily="34" charset="-122"/>
-                          <a:cs typeface="Calibri" pitchFamily="34" charset="-120"/>
+                          <a:latin typeface="Calibri"/>
+                          <a:ea typeface="Calibri"/>
+                          <a:cs typeface="Calibri"/>
                         </a:rPr>
-                        <a:t>perde dinheiro</a:t>
+                        <a:t>perde</a:t>
                       </a:r>
-                      <a:endParaRPr lang="en-US" sz="1300" dirty="0">
-                        <a:latin typeface="Calibri" charset="0"/>
-                        <a:ea typeface="Calibri" charset="0"/>
-                        <a:cs typeface="Calibri" charset="0"/>
+                      <a:r>
+                        <a:rPr lang="en-US" sz="1300" kern="1200" dirty="0">
+                          <a:solidFill>
+                            <a:srgbClr val="5E7C94"/>
+                          </a:solidFill>
+                          <a:latin typeface="Calibri"/>
+                          <a:ea typeface="Calibri"/>
+                          <a:cs typeface="Calibri"/>
+                        </a:rPr>
+                        <a:t> </a:t>
+                      </a:r>
+                      <a:r>
+                        <a:rPr lang="en-US" sz="1300" kern="1200" dirty="0" err="1">
+                          <a:solidFill>
+                            <a:srgbClr val="5E7C94"/>
+                          </a:solidFill>
+                          <a:latin typeface="Calibri"/>
+                          <a:ea typeface="Calibri"/>
+                          <a:cs typeface="Calibri"/>
+                        </a:rPr>
+                        <a:t>dinheiro</a:t>
+                      </a:r>
+                      <a:endParaRPr lang="en-US" sz="1300" kern="1200" dirty="0">
+                        <a:solidFill>
+                          <a:srgbClr val="5E7C94"/>
+                        </a:solidFill>
+                        <a:latin typeface="Calibri"/>
+                        <a:ea typeface="Calibri"/>
+                        <a:cs typeface="Calibri"/>
                       </a:endParaRPr>
                     </a:p>
                   </a:txBody>
@@ -6519,17 +6560,39 @@
                         <a:buNone/>
                       </a:pPr>
                       <a:r>
+                        <a:rPr lang="en-US" sz="1300" b="1" dirty="0" err="1">
+                          <a:solidFill>
+                            <a:srgbClr val="0E1F2B"/>
+                          </a:solidFill>
+                          <a:latin typeface="Calibri"/>
+                          <a:ea typeface="Calibri"/>
+                          <a:cs typeface="Calibri"/>
+                        </a:rPr>
+                        <a:t>Regressão</a:t>
+                      </a:r>
+                      <a:r>
                         <a:rPr lang="en-US" sz="1300" b="1" dirty="0">
                           <a:solidFill>
                             <a:srgbClr val="0E1F2B"/>
                           </a:solidFill>
-                          <a:latin typeface="Calibri" pitchFamily="34" charset="0"/>
-                          <a:ea typeface="Calibri" pitchFamily="34" charset="-122"/>
-                          <a:cs typeface="Calibri" pitchFamily="34" charset="-120"/>
+                          <a:latin typeface="Calibri"/>
+                          <a:ea typeface="Calibri"/>
+                          <a:cs typeface="Calibri"/>
                         </a:rPr>
-                        <a:t>Regressão logística</a:t>
+                        <a:t> </a:t>
                       </a:r>
-                      <a:endParaRPr lang="en-US" sz="1300" dirty="0">
+                      <a:r>
+                        <a:rPr lang="en-US" sz="1300" b="1" dirty="0" err="1">
+                          <a:solidFill>
+                            <a:srgbClr val="0E1F2B"/>
+                          </a:solidFill>
+                          <a:latin typeface="Calibri"/>
+                          <a:ea typeface="Calibri"/>
+                          <a:cs typeface="Calibri"/>
+                        </a:rPr>
+                        <a:t>Logística</a:t>
+                      </a:r>
+                      <a:endParaRPr lang="en-US" sz="1300" dirty="0" err="1">
                         <a:latin typeface="Calibri" charset="0"/>
                         <a:ea typeface="Calibri" charset="0"/>
                         <a:cs typeface="Calibri" charset="0"/>
@@ -6786,15 +6849,15 @@
                         <a:buNone/>
                       </a:pPr>
                       <a:r>
-                        <a:rPr lang="en-US" sz="1300" b="1" dirty="0">
+                        <a:rPr lang="en-US" sz="1300" b="1">
                           <a:solidFill>
                             <a:srgbClr val="0E1F2B"/>
                           </a:solidFill>
-                          <a:latin typeface="Calibri" pitchFamily="34" charset="0"/>
-                          <a:ea typeface="Calibri" pitchFamily="34" charset="-122"/>
-                          <a:cs typeface="Calibri" pitchFamily="34" charset="-120"/>
+                          <a:latin typeface="Calibri"/>
+                          <a:ea typeface="Calibri"/>
+                          <a:cs typeface="Calibri"/>
                         </a:rPr>
-                        <a:t>Random forest</a:t>
+                        <a:t>Random Forest</a:t>
                       </a:r>
                       <a:endParaRPr lang="en-US" sz="1300" dirty="0">
                         <a:latin typeface="Calibri" charset="0"/>

</xml_diff>

<commit_message>
docs: atualizar apresentacao STAR (pptx e pdf) - revisao final
</commit_message>
<xml_diff>
--- a/docs/Apresentacao_Tech_Challenge_1_MLE10_Churn.pptx
+++ b/docs/Apresentacao_Tech_Challenge_1_MLE10_Churn.pptx
@@ -123,7 +123,7 @@
 <p1510:revInfo xmlns:a="http://schemas.openxmlformats.org/drawingml/2006/main" xmlns:r="http://schemas.openxmlformats.org/officeDocument/2006/relationships" xmlns:p1510="http://schemas.microsoft.com/office/powerpoint/2015/10/main">
   <p1510:revLst>
     <p1510:client id="{4C85A211-7014-2639-B4B4-9C710FCE1654}" v="19" dt="2026-06-28T14:29:49.311"/>
-    <p1510:client id="{88413715-0CD2-270D-08AA-4B2FD4070624}" v="32" dt="2026-06-28T22:12:20.985"/>
+    <p1510:client id="{88413715-0CD2-270D-08AA-4B2FD4070624}" v="42" dt="2026-06-28T22:26:24.890"/>
     <p1510:client id="{9C2D4FBA-F40E-43BD-7486-E1CCDFA66667}" v="398" dt="2026-06-28T17:33:08.795"/>
   </p1510:revLst>
 </p1510:revInfo>
@@ -5276,21 +5276,120 @@
           <a:bodyPr wrap="square" lIns="0" tIns="0" rIns="0" bIns="0" rtlCol="0" anchor="ctr"/>
           <a:lstStyle/>
           <a:p>
-            <a:pPr marL="0" indent="0">
-              <a:buNone/>
-            </a:pPr>
+            <a:r>
+              <a:rPr lang="en-US" sz="3200" b="1" dirty="0" err="1">
+                <a:solidFill>
+                  <a:srgbClr val="0E1F2B"/>
+                </a:solidFill>
+                <a:latin typeface="Cambria"/>
+                <a:ea typeface="Cambria"/>
+                <a:cs typeface="Cambria" pitchFamily="34" charset="-120"/>
+              </a:rPr>
+              <a:t>Três</a:t>
+            </a:r>
             <a:r>
               <a:rPr lang="en-US" sz="3200" b="1" dirty="0">
                 <a:solidFill>
                   <a:srgbClr val="0E1F2B"/>
                 </a:solidFill>
-                <a:latin typeface="Cambria" pitchFamily="34" charset="0"/>
-                <a:ea typeface="Cambria" pitchFamily="34" charset="-122"/>
+                <a:latin typeface="Cambria"/>
+                <a:ea typeface="Cambria"/>
                 <a:cs typeface="Cambria" pitchFamily="34" charset="-120"/>
               </a:rPr>
-              <a:t>Quatro modelos empataram. Um deveria vencer.</a:t>
-            </a:r>
-            <a:endParaRPr lang="en-US" sz="3200" dirty="0"/>
+              <a:t> </a:t>
+            </a:r>
+            <a:r>
+              <a:rPr lang="en-US" sz="3200" b="1" dirty="0" err="1">
+                <a:solidFill>
+                  <a:srgbClr val="0E1F2B"/>
+                </a:solidFill>
+                <a:latin typeface="Cambria"/>
+                <a:ea typeface="Cambria"/>
+                <a:cs typeface="Cambria" pitchFamily="34" charset="-120"/>
+              </a:rPr>
+              <a:t>modelos</a:t>
+            </a:r>
+            <a:r>
+              <a:rPr lang="en-US" sz="3200" b="1" dirty="0">
+                <a:solidFill>
+                  <a:srgbClr val="0E1F2B"/>
+                </a:solidFill>
+                <a:latin typeface="Cambria"/>
+                <a:ea typeface="Cambria"/>
+                <a:cs typeface="Cambria" pitchFamily="34" charset="-120"/>
+              </a:rPr>
+              <a:t> </a:t>
+            </a:r>
+            <a:r>
+              <a:rPr lang="en-US" sz="3200" b="1" dirty="0" err="1">
+                <a:solidFill>
+                  <a:srgbClr val="0E1F2B"/>
+                </a:solidFill>
+                <a:latin typeface="Cambria"/>
+                <a:ea typeface="Cambria"/>
+                <a:cs typeface="Cambria" pitchFamily="34" charset="-120"/>
+              </a:rPr>
+              <a:t>empataram</a:t>
+            </a:r>
+            <a:r>
+              <a:rPr lang="en-US" sz="3200" b="1" dirty="0">
+                <a:solidFill>
+                  <a:srgbClr val="0E1F2B"/>
+                </a:solidFill>
+                <a:latin typeface="Cambria"/>
+                <a:ea typeface="Cambria"/>
+                <a:cs typeface="Cambria" pitchFamily="34" charset="-120"/>
+              </a:rPr>
+              <a:t>. Um </a:t>
+            </a:r>
+            <a:r>
+              <a:rPr lang="en-US" sz="3200" b="1" dirty="0" err="1">
+                <a:solidFill>
+                  <a:srgbClr val="0E1F2B"/>
+                </a:solidFill>
+                <a:latin typeface="Cambria"/>
+                <a:ea typeface="Cambria"/>
+                <a:cs typeface="Cambria" pitchFamily="34" charset="-120"/>
+              </a:rPr>
+              <a:t>deveria</a:t>
+            </a:r>
+            <a:r>
+              <a:rPr lang="en-US" sz="3200" b="1" dirty="0">
+                <a:solidFill>
+                  <a:srgbClr val="0E1F2B"/>
+                </a:solidFill>
+                <a:latin typeface="Cambria"/>
+                <a:ea typeface="Cambria"/>
+                <a:cs typeface="Cambria" pitchFamily="34" charset="-120"/>
+              </a:rPr>
+              <a:t> </a:t>
+            </a:r>
+            <a:r>
+              <a:rPr lang="en-US" sz="3200" b="1" dirty="0" err="1">
+                <a:solidFill>
+                  <a:srgbClr val="0E1F2B"/>
+                </a:solidFill>
+                <a:latin typeface="Cambria"/>
+                <a:ea typeface="Cambria"/>
+                <a:cs typeface="Cambria" pitchFamily="34" charset="-120"/>
+              </a:rPr>
+              <a:t>vencer</a:t>
+            </a:r>
+            <a:r>
+              <a:rPr lang="en-US" sz="3200" b="1" dirty="0">
+                <a:solidFill>
+                  <a:srgbClr val="0E1F2B"/>
+                </a:solidFill>
+                <a:latin typeface="Cambria"/>
+                <a:ea typeface="Cambria"/>
+                <a:cs typeface="Cambria" pitchFamily="34" charset="-120"/>
+              </a:rPr>
+              <a:t>.</a:t>
+            </a:r>
+            <a:endParaRPr lang="en-US" sz="3200" dirty="0">
+              <a:latin typeface="Cambria"/>
+              <a:ea typeface="Cambria"/>
+            </a:endParaRPr>
           </a:p>
         </p:txBody>
       </p:sp>

</xml_diff>